<commit_message>
Open demo without sign-in; live demo links in the deck
- Sign-in is now opt-in ({APP}_REQUIRE_LOGIN=true with an admin password), so evaluators land straight on the app
- Live Render link on slides 1, 4 and 6, clickable

Co-Authored-By: Claude Opus 5.5 <noreply@anthropic.com>
</commit_message>
<xml_diff>
--- a/presentation/Jal-drishti_AI_Seva_2026.pptx
+++ b/presentation/Jal-drishti_AI_Seva_2026.pptx
@@ -1504,8 +1504,9 @@
                   <a:srgbClr val="F28C28"/>
                 </a:solidFill>
                 <a:latin typeface="Nirmala UI"/>
-              </a:rPr>
-              <a:t>[deployment link]</a:t>
+                <a:hlinkClick r:id="rId4"/>
+              </a:rPr>
+              <a:t>jal-drishti-enz2.onrender.com</a:t>
             </a:r>
           </a:p>
         </p:txBody>
@@ -6477,8 +6478,9 @@
                   <a:srgbClr val="F28C28"/>
                 </a:solidFill>
                 <a:latin typeface="Nirmala UI"/>
-              </a:rPr>
-              <a:t>[deployment link]</a:t>
+                <a:hlinkClick r:id="rId3"/>
+              </a:rPr>
+              <a:t>jal-drishti-enz2.onrender.com</a:t>
             </a:r>
           </a:p>
         </p:txBody>
@@ -9140,8 +9142,9 @@
                 <a:latin typeface="Nirmala UI" pitchFamily="34" charset="0"/>
                 <a:ea typeface="Nirmala UI" pitchFamily="34" charset="-122"/>
                 <a:cs typeface="Nirmala UI" pitchFamily="34" charset="-120"/>
-              </a:rPr>
-              <a:t>[deployment link]</a:t>
+                <a:hlinkClick r:id="rId3"/>
+              </a:rPr>
+              <a:t>jal-drishti-enz2.onrender.com</a:t>
             </a:r>
           </a:p>
         </p:txBody>

</xml_diff>

<commit_message>
Remove NASA ARSET wording from slides 1 and 4; orange demo links
Co-Authored-By: Claude Opus 5.5 <noreply@anthropic.com>
</commit_message>
<xml_diff>
--- a/presentation/Jal-drishti_AI_Seva_2026.pptx
+++ b/presentation/Jal-drishti_AI_Seva_2026.pptx
@@ -1480,7 +1480,7 @@
                 </a:solidFill>
                 <a:latin typeface="Nirmala UI"/>
               </a:rPr>
-              <a:t>• Sentinel-2, method after NASA ARSET</a:t>
+              <a:t>• Sentinel-2 images, every stretch, every month</a:t>
             </a:r>
           </a:p>
           <a:p>
@@ -5826,7 +5826,7 @@
                 <a:ea typeface="Nirmala UI" pitchFamily="34" charset="-122"/>
                 <a:cs typeface="Nirmala UI" pitchFamily="34" charset="-120"/>
               </a:rPr>
-              <a:t>NASA ARSET inland water quality</a:t>
+              <a:t>weed, turbidity, algae vs 2019-23</a:t>
             </a:r>
           </a:p>
           <a:p>
@@ -9336,10 +9336,10 @@
         <a:srgbClr val="70AD47"/>
       </a:accent6>
       <a:hlink>
-        <a:srgbClr val="0563C1"/>
+        <a:srgbClr val="F28C28"/>
       </a:hlink>
       <a:folHlink>
-        <a:srgbClr val="954F72"/>
+        <a:srgbClr val="F28C28"/>
       </a:folHlink>
     </a:clrScheme>
     <a:fontScheme name="Office">

</xml_diff>

<commit_message>
Slide 4: rename Partners to 'Partners to approach'
None are engaged yet; the heading now says so.

Co-Authored-By: Claude Opus 5.5 <noreply@anthropic.com>
</commit_message>
<xml_diff>
--- a/presentation/Jal-drishti_AI_Seva_2026.pptx
+++ b/presentation/Jal-drishti_AI_Seva_2026.pptx
@@ -6289,10 +6289,13 @@
           <a:lstStyle/>
           <a:p>
             <a:pPr marL="0" indent="0">
+              <a:spcAft>
+                <a:spcPts val="300"/>
+              </a:spcAft>
               <a:buNone/>
             </a:pPr>
             <a:r>
-              <a:rPr lang="en-US" sz="1200" b="1" dirty="0">
+              <a:rPr lang="en-US" sz="1200" b="1" dirty="0" i="0">
                 <a:solidFill>
                   <a:srgbClr val="1B2A5C"/>
                 </a:solidFill>
@@ -6300,7 +6303,7 @@
                 <a:ea typeface="Nirmala UI" pitchFamily="34" charset="-122"/>
                 <a:cs typeface="Nirmala UI" pitchFamily="34" charset="-120"/>
               </a:rPr>
-              <a:t>Partners</a:t>
+              <a:t>Partners to approach</a:t>
             </a:r>
             <a:endParaRPr lang="en-US" sz="1200" dirty="0"/>
           </a:p>

</xml_diff>

<commit_message>
Deck: team and slide updates
- Team: add Hriday Kadam

Co-Authored-By: Claude Opus 5.5 <noreply@anthropic.com>
</commit_message>
<xml_diff>
--- a/presentation/Jal-drishti_AI_Seva_2026.pptx
+++ b/presentation/Jal-drishti_AI_Seva_2026.pptx
@@ -1364,7 +1364,7 @@
                 </a:solidFill>
                 <a:latin typeface="Nirmala UI"/>
               </a:rPr>
-              <a:t>Sujal Chondekar  ·  Kshitij Mehrotra</a:t>
+              <a:t>Sujal Chondekar  ·  Kshitij Mehrotra  ·  Hriday Kadam</a:t>
             </a:r>
           </a:p>
           <a:p>
@@ -8435,7 +8435,7 @@
                 <a:ea typeface="Nirmala UI" pitchFamily="34" charset="-122"/>
                 <a:cs typeface="Nirmala UI" pitchFamily="34" charset="-120"/>
               </a:rPr>
-              <a:t>SH</a:t>
+              <a:t>HK</a:t>
             </a:r>
             <a:endParaRPr lang="en-US" sz="700" dirty="0"/>
           </a:p>
@@ -8477,7 +8477,7 @@
                 <a:ea typeface="Nirmala UI" pitchFamily="34" charset="-122"/>
                 <a:cs typeface="Nirmala UI" pitchFamily="34" charset="-120"/>
               </a:rPr>
-              <a:t>Dr. Swati Hira</a:t>
+              <a:t>Hriday Kadam</a:t>
             </a:r>
             <a:endParaRPr lang="en-US" sz="1050" dirty="0"/>
           </a:p>
@@ -8519,6 +8519,240 @@
                 <a:ea typeface="Nirmala UI" pitchFamily="34" charset="-122"/>
                 <a:cs typeface="Nirmala UI" pitchFamily="34" charset="-120"/>
               </a:rPr>
+              <a:t>Team member</a:t>
+            </a:r>
+            <a:endParaRPr lang="en-US" sz="900" dirty="0"/>
+          </a:p>
+        </p:txBody>
+      </p:sp>
+      <p:sp>
+        <p:nvSpPr>
+          <p:cNvPr id="23" name="Text 21"/>
+          <p:cNvSpPr txBox="1"/>
+          <p:nvPr/>
+        </p:nvSpPr>
+        <p:spPr>
+          <a:xfrm>
+            <a:off x="1207008" y="3108960"/>
+            <a:ext cx="1280160" cy="411480"/>
+          </a:xfrm>
+          <a:prstGeom prst="rect">
+            <a:avLst/>
+          </a:prstGeom>
+          <a:noFill/>
+          <a:ln/>
+        </p:spPr>
+        <p:txBody>
+          <a:bodyPr wrap="square" lIns="0" tIns="0" rIns="0" bIns="0" rtlCol="0" anchor="t"/>
+          <a:lstStyle/>
+          <a:p>
+            <a:pPr marL="0" indent="0">
+              <a:spcAft>
+                <a:spcPts val="300"/>
+              </a:spcAft>
+              <a:buNone/>
+            </a:pPr>
+            <a:r>
+              <a:rPr lang="en-US" sz="800" i="0" dirty="0" b="0">
+                <a:solidFill>
+                  <a:srgbClr val="C9D2EC"/>
+                </a:solidFill>
+                <a:latin typeface="Nirmala UI" pitchFamily="34" charset="0"/>
+                <a:ea typeface="Nirmala UI" pitchFamily="34" charset="-122"/>
+                <a:cs typeface="Nirmala UI" pitchFamily="34" charset="-120"/>
+              </a:rPr>
+              <a:t/>
+            </a:r>
+            <a:endParaRPr lang="en-US" sz="850" dirty="0"/>
+          </a:p>
+        </p:txBody>
+      </p:sp>
+      <p:sp>
+        <p:nvSpPr>
+          <p:cNvPr id="24" name="Shape 22"/>
+          <p:cNvSpPr/>
+          <p:nvPr/>
+        </p:nvSpPr>
+        <p:spPr>
+          <a:xfrm>
+            <a:off x="2697480" y="2468880"/>
+            <a:ext cx="2103120" cy="1143000"/>
+          </a:xfrm>
+          <a:prstGeom prst="roundRect">
+            <a:avLst>
+              <a:gd name="adj" fmla="val 6400"/>
+            </a:avLst>
+          </a:prstGeom>
+          <a:solidFill>
+            <a:srgbClr val="253870"/>
+          </a:solidFill>
+          <a:ln w="12700">
+            <a:solidFill>
+              <a:srgbClr val="253870"/>
+            </a:solidFill>
+            <a:prstDash val="solid"/>
+          </a:ln>
+        </p:spPr>
+        <p:txBody>
+          <a:bodyPr/>
+          <a:lstStyle/>
+          <a:p>
+            <a:endParaRPr lang="en-IN"/>
+          </a:p>
+        </p:txBody>
+      </p:sp>
+      <p:sp>
+        <p:nvSpPr>
+          <p:cNvPr id="25" name="Shape 23"/>
+          <p:cNvSpPr/>
+          <p:nvPr/>
+        </p:nvSpPr>
+        <p:spPr>
+          <a:xfrm>
+            <a:off x="2834640" y="2651760"/>
+            <a:ext cx="502920" cy="502920"/>
+          </a:xfrm>
+          <a:prstGeom prst="ellipse">
+            <a:avLst/>
+          </a:prstGeom>
+          <a:solidFill>
+            <a:srgbClr val="3A4C85"/>
+          </a:solidFill>
+          <a:ln w="12700">
+            <a:solidFill>
+              <a:srgbClr val="F28C28"/>
+            </a:solidFill>
+            <a:prstDash val="solid"/>
+          </a:ln>
+        </p:spPr>
+        <p:txBody>
+          <a:bodyPr/>
+          <a:lstStyle/>
+          <a:p>
+            <a:endParaRPr lang="en-IN"/>
+          </a:p>
+        </p:txBody>
+      </p:sp>
+      <p:sp>
+        <p:nvSpPr>
+          <p:cNvPr id="26" name="Text 24"/>
+          <p:cNvSpPr txBox="1"/>
+          <p:nvPr/>
+        </p:nvSpPr>
+        <p:spPr>
+          <a:xfrm>
+            <a:off x="2834640" y="2651760"/>
+            <a:ext cx="502920" cy="502920"/>
+          </a:xfrm>
+          <a:prstGeom prst="rect">
+            <a:avLst/>
+          </a:prstGeom>
+          <a:noFill/>
+          <a:ln/>
+        </p:spPr>
+        <p:txBody>
+          <a:bodyPr wrap="square" lIns="0" tIns="0" rIns="0" bIns="0" rtlCol="0" anchor="ctr"/>
+          <a:lstStyle/>
+          <a:p>
+            <a:pPr marL="0" indent="0" algn="ctr">
+              <a:spcAft>
+                <a:spcPts val="300"/>
+              </a:spcAft>
+              <a:buNone/>
+            </a:pPr>
+            <a:r>
+              <a:rPr lang="en-US" sz="1100" dirty="0" i="0" b="1">
+                <a:solidFill>
+                  <a:srgbClr val="FFFFFF"/>
+                </a:solidFill>
+                <a:latin typeface="Nirmala UI" pitchFamily="34" charset="0"/>
+                <a:ea typeface="Nirmala UI" pitchFamily="34" charset="-122"/>
+                <a:cs typeface="Nirmala UI" pitchFamily="34" charset="-120"/>
+              </a:rPr>
+              <a:t>SH</a:t>
+            </a:r>
+            <a:endParaRPr lang="en-US" sz="700" dirty="0"/>
+          </a:p>
+        </p:txBody>
+      </p:sp>
+      <p:sp>
+        <p:nvSpPr>
+          <p:cNvPr id="27" name="Text 25"/>
+          <p:cNvSpPr txBox="1"/>
+          <p:nvPr/>
+        </p:nvSpPr>
+        <p:spPr>
+          <a:xfrm>
+            <a:off x="3447288" y="2633472"/>
+            <a:ext cx="1280160" cy="256032"/>
+          </a:xfrm>
+          <a:prstGeom prst="rect">
+            <a:avLst/>
+          </a:prstGeom>
+          <a:noFill/>
+          <a:ln/>
+        </p:spPr>
+        <p:txBody>
+          <a:bodyPr wrap="square" lIns="0" tIns="0" rIns="0" bIns="0" rtlCol="0" anchor="t"/>
+          <a:lstStyle/>
+          <a:p>
+            <a:pPr marL="0" indent="0">
+              <a:spcAft>
+                <a:spcPts val="300"/>
+              </a:spcAft>
+              <a:buNone/>
+            </a:pPr>
+            <a:r>
+              <a:rPr lang="en-US" sz="1050" b="1" dirty="0" i="0">
+                <a:solidFill>
+                  <a:srgbClr val="FFFFFF"/>
+                </a:solidFill>
+                <a:latin typeface="Nirmala UI" pitchFamily="34" charset="0"/>
+                <a:ea typeface="Nirmala UI" pitchFamily="34" charset="-122"/>
+                <a:cs typeface="Nirmala UI" pitchFamily="34" charset="-120"/>
+              </a:rPr>
+              <a:t>Dr. Swati Hira</a:t>
+            </a:r>
+            <a:endParaRPr lang="en-US" sz="1050" dirty="0"/>
+          </a:p>
+        </p:txBody>
+      </p:sp>
+      <p:sp>
+        <p:nvSpPr>
+          <p:cNvPr id="28" name="Text 26"/>
+          <p:cNvSpPr txBox="1"/>
+          <p:nvPr/>
+        </p:nvSpPr>
+        <p:spPr>
+          <a:xfrm>
+            <a:off x="3447288" y="2889504"/>
+            <a:ext cx="1280160" cy="201168"/>
+          </a:xfrm>
+          <a:prstGeom prst="rect">
+            <a:avLst/>
+          </a:prstGeom>
+          <a:noFill/>
+          <a:ln/>
+        </p:spPr>
+        <p:txBody>
+          <a:bodyPr wrap="square" lIns="0" tIns="0" rIns="0" bIns="0" rtlCol="0" anchor="t"/>
+          <a:lstStyle/>
+          <a:p>
+            <a:pPr marL="0" indent="0">
+              <a:spcAft>
+                <a:spcPts val="300"/>
+              </a:spcAft>
+              <a:buNone/>
+            </a:pPr>
+            <a:r>
+              <a:rPr lang="en-US" sz="900" i="0" dirty="0" b="0">
+                <a:solidFill>
+                  <a:srgbClr val="F28C28"/>
+                </a:solidFill>
+                <a:latin typeface="Nirmala UI" pitchFamily="34" charset="0"/>
+                <a:ea typeface="Nirmala UI" pitchFamily="34" charset="-122"/>
+                <a:cs typeface="Nirmala UI" pitchFamily="34" charset="-120"/>
+              </a:rPr>
               <a:t>Faculty mentor</a:t>
             </a:r>
             <a:endParaRPr lang="en-US" sz="900" dirty="0"/>
@@ -8527,13 +8761,13 @@
       </p:sp>
       <p:sp>
         <p:nvSpPr>
-          <p:cNvPr id="23" name="Text 21"/>
-          <p:cNvSpPr txBox="1"/>
-          <p:nvPr/>
-        </p:nvSpPr>
-        <p:spPr>
-          <a:xfrm>
-            <a:off x="1207008" y="3108960"/>
+          <p:cNvPr id="29" name="Text 27"/>
+          <p:cNvSpPr txBox="1"/>
+          <p:nvPr/>
+        </p:nvSpPr>
+        <p:spPr>
+          <a:xfrm>
+            <a:off x="3447288" y="3108960"/>
             <a:ext cx="1280160" cy="411480"/>
           </a:xfrm>
           <a:prstGeom prst="rect">

</xml_diff>